<commit_message>
Add playground API cheat sheet, detailed presenter script, and slide deck sync.
Includes walk_slides.py for interactive rehearsal, expanded AMD query/parameter examples, and updated PPTX resources slide pointing to facilitator docs.

Co-authored-by: Cursor <cursoragent@cursor.com>
</commit_message>
<xml_diff>
--- a/workshop-app/60-min-workshop-slides.pptx
+++ b/workshop-app/60-min-workshop-slides.pptx
@@ -3541,7 +3541,7 @@
               </a:defRPr>
             </a:pPr>
             <a:r>
-              <a:t>3–18 min · facilitator leads; attendees follow along</a:t>
+              <a:t>3–18 min · facilitator leads; see PLAYGROUND-API-WALKTHROUGH.md for queries + params</a:t>
             </a:r>
           </a:p>
         </p:txBody>
@@ -5740,7 +5740,7 @@
               </a:defRPr>
             </a:pPr>
             <a:r>
-              <a:t>FACILITATOR-60MIN.md · HERMES-DESKTOP-SETUP.md</a:t>
+              <a:t>PLAYGROUND-API-WALKTHROUGH.md · SLIDE-PRESENTER-SCRIPT.md</a:t>
             </a:r>
           </a:p>
           <a:p>
@@ -5755,7 +5755,7 @@
               </a:defRPr>
             </a:pPr>
             <a:r>
-              <a:t>COMMUNITY-CONTINUATION.md (Discord only)</a:t>
+              <a:t>FACILITATOR-60MIN.md · HERMES-DESKTOP-SETUP.md</a:t>
             </a:r>
           </a:p>
           <a:p>
@@ -5770,7 +5770,22 @@
               </a:defRPr>
             </a:pPr>
             <a:r>
-              <a:t>Preflight: ./preflight.sh</a:t>
+              <a:t>GitHub: github.com/rayleegit/hermes-youcom-workshop</a:t>
+            </a:r>
+          </a:p>
+          <a:p>
+            <a:pPr>
+              <a:spcAft>
+                <a:spcPts val="1000"/>
+              </a:spcAft>
+              <a:defRPr sz="2000">
+                <a:solidFill>
+                  <a:srgbClr val="E6E8F0"/>
+                </a:solidFill>
+              </a:defRPr>
+            </a:pPr>
+            <a:r>
+              <a:t>Discord: discord.gg/2C4WgryxSD</a:t>
             </a:r>
           </a:p>
         </p:txBody>

</xml_diff>